<commit_message>
Squashed commit of the following:
commit b41e9370f6f00b1910bb521671fd7df3a542096e
Author: Haruya Ishida <harusaku.110906@gmail.com>
Date:   Tue Mar 17 13:30:29 2026 +0900

    fig1のまとめた数の記述を修正

commit e83bce7c5b3710cb067052e3860cd1222eb88013
Author: Haruya Ishida <harusaku.110906@gmail.com>
Date:   Tue Mar 17 12:06:11 2026 +0900

    図に線が入る問題を修正
    アルファチャンネルが原因でした

commit 05554ac3ed46a091c1d12dfc860e26b30aa124ec
Author: Haruya Ishida <harusaku.110906@gmail.com>
Date:   Tue Mar 17 10:39:01 2026 +0900

    最終修正
</commit_message>
<xml_diff>
--- a/figs/slip_length_summary/output/fig.pptx
+++ b/figs/slip_length_summary/output/fig.pptx
@@ -5,7 +5,7 @@
     <p:sldMasterId id="2147483648" r:id="rId4"/>
   </p:sldMasterIdLst>
   <p:notesMasterIdLst>
-    <p:notesMasterId r:id="rId15"/>
+    <p:notesMasterId r:id="rId16"/>
   </p:notesMasterIdLst>
   <p:sldIdLst>
     <p:sldId id="257" r:id="rId5"/>
@@ -18,6 +18,7 @@
     <p:sldId id="264" r:id="rId12"/>
     <p:sldId id="265" r:id="rId13"/>
     <p:sldId id="266" r:id="rId14"/>
+    <p:sldId id="267" r:id="rId15"/>
   </p:sldIdLst>
   <p:sldSz cx="12192000" cy="6858000"/>
   <p:notesSz cx="6858000" cy="9144000"/>
@@ -209,7 +210,7 @@
           <a:p>
             <a:fld id="{58ACC529-06C9-45FD-94D7-552AA2810228}" type="datetimeFigureOut">
               <a:rPr kumimoji="1" lang="ja-JP" altLang="en-US" smtClean="0"/>
-              <a:t>2026/3/5</a:t>
+              <a:t>2026/3/16</a:t>
             </a:fld>
             <a:endParaRPr kumimoji="1" lang="ja-JP" altLang="en-US"/>
           </a:p>
@@ -1072,6 +1073,109 @@
     <p:extLst>
       <p:ext uri="{BB962C8B-B14F-4D97-AF65-F5344CB8AC3E}">
         <p14:creationId xmlns:p14="http://schemas.microsoft.com/office/powerpoint/2010/main" val="560887523"/>
+      </p:ext>
+    </p:extLst>
+  </p:cSld>
+  <p:clrMapOvr>
+    <a:masterClrMapping/>
+  </p:clrMapOvr>
+</p:sld>
+</file>
+
+<file path=ppt/slides/slide11.xml><?xml version="1.0" encoding="utf-8"?>
+<p:sld xmlns:a="http://schemas.openxmlformats.org/drawingml/2006/main" xmlns:r="http://schemas.openxmlformats.org/officeDocument/2006/relationships" xmlns:p="http://schemas.openxmlformats.org/presentationml/2006/main">
+  <p:cSld>
+    <p:spTree>
+      <p:nvGrpSpPr>
+        <p:cNvPr id="1" name=""/>
+        <p:cNvGrpSpPr/>
+        <p:nvPr/>
+      </p:nvGrpSpPr>
+      <p:grpSpPr>
+        <a:xfrm>
+          <a:off x="0" y="0"/>
+          <a:ext cx="0" cy="0"/>
+          <a:chOff x="0" y="0"/>
+          <a:chExt cx="0" cy="0"/>
+        </a:xfrm>
+      </p:grpSpPr>
+      <p:pic>
+        <p:nvPicPr>
+          <p:cNvPr id="3" name="グラフィックス 2">
+            <a:extLst>
+              <a:ext uri="{FF2B5EF4-FFF2-40B4-BE49-F238E27FC236}">
+                <a16:creationId xmlns:a16="http://schemas.microsoft.com/office/drawing/2014/main" id="{764A89DB-7E1D-88AF-3D1F-3FD792D54912}"/>
+              </a:ext>
+            </a:extLst>
+          </p:cNvPr>
+          <p:cNvPicPr>
+            <a:picLocks noChangeAspect="1"/>
+          </p:cNvPicPr>
+          <p:nvPr/>
+        </p:nvPicPr>
+        <p:blipFill>
+          <a:blip r:embed="rId2">
+            <a:extLst>
+              <a:ext uri="{96DAC541-7B7A-43D3-8B79-37D633B846F1}">
+                <asvg:svgBlip xmlns:asvg="http://schemas.microsoft.com/office/drawing/2016/SVG/main" r:embed="rId3"/>
+              </a:ext>
+            </a:extLst>
+          </a:blip>
+          <a:srcRect t="11793" b="11880"/>
+          <a:stretch>
+            <a:fillRect/>
+          </a:stretch>
+        </p:blipFill>
+        <p:spPr>
+          <a:xfrm>
+            <a:off x="8686800" y="1394691"/>
+            <a:ext cx="2286000" cy="4064000"/>
+          </a:xfrm>
+          <a:prstGeom prst="rect">
+            <a:avLst/>
+          </a:prstGeom>
+        </p:spPr>
+      </p:pic>
+      <p:pic>
+        <p:nvPicPr>
+          <p:cNvPr id="5" name="グラフィックス 4">
+            <a:extLst>
+              <a:ext uri="{FF2B5EF4-FFF2-40B4-BE49-F238E27FC236}">
+                <a16:creationId xmlns:a16="http://schemas.microsoft.com/office/drawing/2014/main" id="{62B558FF-74FA-EAE7-61BA-3E6C34B8BF31}"/>
+              </a:ext>
+            </a:extLst>
+          </p:cNvPr>
+          <p:cNvPicPr>
+            <a:picLocks noChangeAspect="1"/>
+          </p:cNvPicPr>
+          <p:nvPr/>
+        </p:nvPicPr>
+        <p:blipFill>
+          <a:blip r:embed="rId4">
+            <a:extLst>
+              <a:ext uri="{96DAC541-7B7A-43D3-8B79-37D633B846F1}">
+                <asvg:svgBlip xmlns:asvg="http://schemas.microsoft.com/office/drawing/2016/SVG/main" r:embed="rId5"/>
+              </a:ext>
+            </a:extLst>
+          </a:blip>
+          <a:stretch>
+            <a:fillRect/>
+          </a:stretch>
+        </p:blipFill>
+        <p:spPr>
+          <a:xfrm>
+            <a:off x="3505200" y="1476375"/>
+            <a:ext cx="5181600" cy="3905250"/>
+          </a:xfrm>
+          <a:prstGeom prst="rect">
+            <a:avLst/>
+          </a:prstGeom>
+        </p:spPr>
+      </p:pic>
+    </p:spTree>
+    <p:extLst>
+      <p:ext uri="{BB962C8B-B14F-4D97-AF65-F5344CB8AC3E}">
+        <p14:creationId xmlns:p14="http://schemas.microsoft.com/office/powerpoint/2010/main" val="1543257032"/>
       </p:ext>
     </p:extLst>
   </p:cSld>
@@ -2682,14 +2786,6 @@
 </file>
 
 <file path=customXml/item1.xml><?xml version="1.0" encoding="utf-8"?>
-<p:properties xmlns:p="http://schemas.microsoft.com/office/2006/metadata/properties" xmlns:xsi="http://www.w3.org/2001/XMLSchema-instance" xmlns:pc="http://schemas.microsoft.com/office/infopath/2007/PartnerControls">
-  <documentManagement>
-    <_activity xmlns="a4af94e1-c1fc-4949-80ee-6d0f2b25a4fd" xsi:nil="true"/>
-  </documentManagement>
-</p:properties>
-</file>
-
-<file path=customXml/item2.xml><?xml version="1.0" encoding="utf-8"?>
 <ct:contentTypeSchema xmlns:ct="http://schemas.microsoft.com/office/2006/metadata/contentType" xmlns:ma="http://schemas.microsoft.com/office/2006/metadata/properties/metaAttributes" ct:_="" ma:_="" ma:contentTypeName="ドキュメント" ma:contentTypeID="0x01010001977AFA83253148B9A11DE7E57585DA" ma:contentTypeVersion="18" ma:contentTypeDescription="新しいドキュメントを作成します。" ma:contentTypeScope="" ma:versionID="c33b06d1a59709aebae5ef90ac421293">
   <xsd:schema xmlns:xsd="http://www.w3.org/2001/XMLSchema" xmlns:xs="http://www.w3.org/2001/XMLSchema" xmlns:p="http://schemas.microsoft.com/office/2006/metadata/properties" xmlns:ns3="a4af94e1-c1fc-4949-80ee-6d0f2b25a4fd" xmlns:ns4="6e67e666-c3e9-4393-909a-82e166baf630" targetNamespace="http://schemas.microsoft.com/office/2006/metadata/properties" ma:root="true" ma:fieldsID="5929bf68818a63ba6b6aa8003b159019" ns3:_="" ns4:_="">
     <xsd:import namespace="a4af94e1-c1fc-4949-80ee-6d0f2b25a4fd"/>
@@ -2942,6 +3038,14 @@
 </ct:contentTypeSchema>
 </file>
 
+<file path=customXml/item2.xml><?xml version="1.0" encoding="utf-8"?>
+<p:properties xmlns:p="http://schemas.microsoft.com/office/2006/metadata/properties" xmlns:xsi="http://www.w3.org/2001/XMLSchema-instance" xmlns:pc="http://schemas.microsoft.com/office/infopath/2007/PartnerControls">
+  <documentManagement>
+    <_activity xmlns="a4af94e1-c1fc-4949-80ee-6d0f2b25a4fd" xsi:nil="true"/>
+  </documentManagement>
+</p:properties>
+</file>
+
 <file path=customXml/item3.xml><?xml version="1.0" encoding="utf-8"?>
 <?mso-contentType ?>
 <FormTemplates xmlns="http://schemas.microsoft.com/sharepoint/v3/contenttype/forms">
@@ -2952,23 +3056,6 @@
 </file>
 
 <file path=customXml/itemProps1.xml><?xml version="1.0" encoding="utf-8"?>
-<ds:datastoreItem xmlns:ds="http://schemas.openxmlformats.org/officeDocument/2006/customXml" ds:itemID="{B536A920-CFA6-45F7-AAF4-D5E5B2A432A5}">
-  <ds:schemaRefs>
-    <ds:schemaRef ds:uri="http://schemas.microsoft.com/office/infopath/2007/PartnerControls"/>
-    <ds:schemaRef ds:uri="http://schemas.microsoft.com/office/2006/metadata/properties"/>
-    <ds:schemaRef ds:uri="http://schemas.microsoft.com/office/2006/documentManagement/types"/>
-    <ds:schemaRef ds:uri="http://purl.org/dc/elements/1.1/"/>
-    <ds:schemaRef ds:uri="http://purl.org/dc/dcmitype/"/>
-    <ds:schemaRef ds:uri="http://www.w3.org/XML/1998/namespace"/>
-    <ds:schemaRef ds:uri="a4af94e1-c1fc-4949-80ee-6d0f2b25a4fd"/>
-    <ds:schemaRef ds:uri="http://schemas.openxmlformats.org/package/2006/metadata/core-properties"/>
-    <ds:schemaRef ds:uri="6e67e666-c3e9-4393-909a-82e166baf630"/>
-    <ds:schemaRef ds:uri="http://purl.org/dc/terms/"/>
-  </ds:schemaRefs>
-</ds:datastoreItem>
-</file>
-
-<file path=customXml/itemProps2.xml><?xml version="1.0" encoding="utf-8"?>
 <ds:datastoreItem xmlns:ds="http://schemas.openxmlformats.org/officeDocument/2006/customXml" ds:itemID="{4CF7E964-C6F6-44DA-86BC-C4F5D23786D9}">
   <ds:schemaRefs>
     <ds:schemaRef ds:uri="http://schemas.microsoft.com/office/2006/metadata/contentType"/>
@@ -2987,6 +3074,23 @@
 </ds:datastoreItem>
 </file>
 
+<file path=customXml/itemProps2.xml><?xml version="1.0" encoding="utf-8"?>
+<ds:datastoreItem xmlns:ds="http://schemas.openxmlformats.org/officeDocument/2006/customXml" ds:itemID="{B536A920-CFA6-45F7-AAF4-D5E5B2A432A5}">
+  <ds:schemaRefs>
+    <ds:schemaRef ds:uri="http://schemas.microsoft.com/office/infopath/2007/PartnerControls"/>
+    <ds:schemaRef ds:uri="http://schemas.microsoft.com/office/2006/metadata/properties"/>
+    <ds:schemaRef ds:uri="http://schemas.microsoft.com/office/2006/documentManagement/types"/>
+    <ds:schemaRef ds:uri="http://purl.org/dc/elements/1.1/"/>
+    <ds:schemaRef ds:uri="http://purl.org/dc/dcmitype/"/>
+    <ds:schemaRef ds:uri="http://www.w3.org/XML/1998/namespace"/>
+    <ds:schemaRef ds:uri="a4af94e1-c1fc-4949-80ee-6d0f2b25a4fd"/>
+    <ds:schemaRef ds:uri="http://schemas.openxmlformats.org/package/2006/metadata/core-properties"/>
+    <ds:schemaRef ds:uri="6e67e666-c3e9-4393-909a-82e166baf630"/>
+    <ds:schemaRef ds:uri="http://purl.org/dc/terms/"/>
+  </ds:schemaRefs>
+</ds:datastoreItem>
+</file>
+
 <file path=customXml/itemProps3.xml><?xml version="1.0" encoding="utf-8"?>
 <ds:datastoreItem xmlns:ds="http://schemas.openxmlformats.org/officeDocument/2006/customXml" ds:itemID="{A32B4A66-F859-40E3-BB80-2813DE49481C}">
   <ds:schemaRefs>

</xml_diff>

<commit_message>
Remove supporting_diff.tex and update supporting_information.tex to include a custom bibliography section for supporting references.
</commit_message>
<xml_diff>
--- a/figs/slip_length_summary/output/fig.pptx
+++ b/figs/slip_length_summary/output/fig.pptx
@@ -5,7 +5,7 @@
     <p:sldMasterId id="2147483648" r:id="rId4"/>
   </p:sldMasterIdLst>
   <p:notesMasterIdLst>
-    <p:notesMasterId r:id="rId16"/>
+    <p:notesMasterId r:id="rId17"/>
   </p:notesMasterIdLst>
   <p:sldIdLst>
     <p:sldId id="257" r:id="rId5"/>
@@ -19,6 +19,7 @@
     <p:sldId id="265" r:id="rId13"/>
     <p:sldId id="266" r:id="rId14"/>
     <p:sldId id="267" r:id="rId15"/>
+    <p:sldId id="268" r:id="rId16"/>
   </p:sldIdLst>
   <p:sldSz cx="12192000" cy="6858000"/>
   <p:notesSz cx="6858000" cy="9144000"/>
@@ -210,7 +211,7 @@
           <a:p>
             <a:fld id="{58ACC529-06C9-45FD-94D7-552AA2810228}" type="datetimeFigureOut">
               <a:rPr kumimoji="1" lang="ja-JP" altLang="en-US" smtClean="0"/>
-              <a:t>2026/3/16</a:t>
+              <a:t>2026/3/18</a:t>
             </a:fld>
             <a:endParaRPr kumimoji="1" lang="ja-JP" altLang="en-US"/>
           </a:p>
@@ -1176,6 +1177,109 @@
     <p:extLst>
       <p:ext uri="{BB962C8B-B14F-4D97-AF65-F5344CB8AC3E}">
         <p14:creationId xmlns:p14="http://schemas.microsoft.com/office/powerpoint/2010/main" val="1543257032"/>
+      </p:ext>
+    </p:extLst>
+  </p:cSld>
+  <p:clrMapOvr>
+    <a:masterClrMapping/>
+  </p:clrMapOvr>
+</p:sld>
+</file>
+
+<file path=ppt/slides/slide12.xml><?xml version="1.0" encoding="utf-8"?>
+<p:sld xmlns:a="http://schemas.openxmlformats.org/drawingml/2006/main" xmlns:r="http://schemas.openxmlformats.org/officeDocument/2006/relationships" xmlns:p="http://schemas.openxmlformats.org/presentationml/2006/main">
+  <p:cSld>
+    <p:spTree>
+      <p:nvGrpSpPr>
+        <p:cNvPr id="1" name=""/>
+        <p:cNvGrpSpPr/>
+        <p:nvPr/>
+      </p:nvGrpSpPr>
+      <p:grpSpPr>
+        <a:xfrm>
+          <a:off x="0" y="0"/>
+          <a:ext cx="0" cy="0"/>
+          <a:chOff x="0" y="0"/>
+          <a:chExt cx="0" cy="0"/>
+        </a:xfrm>
+      </p:grpSpPr>
+      <p:pic>
+        <p:nvPicPr>
+          <p:cNvPr id="3" name="グラフィックス 2">
+            <a:extLst>
+              <a:ext uri="{FF2B5EF4-FFF2-40B4-BE49-F238E27FC236}">
+                <a16:creationId xmlns:a16="http://schemas.microsoft.com/office/drawing/2014/main" id="{36EEFB13-760E-B2BF-1562-0D42D4AC7F4A}"/>
+              </a:ext>
+            </a:extLst>
+          </p:cNvPr>
+          <p:cNvPicPr>
+            <a:picLocks noChangeAspect="1"/>
+          </p:cNvPicPr>
+          <p:nvPr/>
+        </p:nvPicPr>
+        <p:blipFill>
+          <a:blip r:embed="rId2">
+            <a:extLst>
+              <a:ext uri="{96DAC541-7B7A-43D3-8B79-37D633B846F1}">
+                <asvg:svgBlip xmlns:asvg="http://schemas.microsoft.com/office/drawing/2016/SVG/main" r:embed="rId3"/>
+              </a:ext>
+            </a:extLst>
+          </a:blip>
+          <a:stretch>
+            <a:fillRect/>
+          </a:stretch>
+        </p:blipFill>
+        <p:spPr>
+          <a:xfrm>
+            <a:off x="2627745" y="1587211"/>
+            <a:ext cx="5181600" cy="3905250"/>
+          </a:xfrm>
+          <a:prstGeom prst="rect">
+            <a:avLst/>
+          </a:prstGeom>
+        </p:spPr>
+      </p:pic>
+      <p:pic>
+        <p:nvPicPr>
+          <p:cNvPr id="5" name="グラフィックス 4">
+            <a:extLst>
+              <a:ext uri="{FF2B5EF4-FFF2-40B4-BE49-F238E27FC236}">
+                <a16:creationId xmlns:a16="http://schemas.microsoft.com/office/drawing/2014/main" id="{4E1A1D50-DE6A-E6A2-3655-9467AB5D2CC3}"/>
+              </a:ext>
+            </a:extLst>
+          </p:cNvPr>
+          <p:cNvPicPr>
+            <a:picLocks noChangeAspect="1"/>
+          </p:cNvPicPr>
+          <p:nvPr/>
+        </p:nvPicPr>
+        <p:blipFill>
+          <a:blip r:embed="rId4">
+            <a:extLst>
+              <a:ext uri="{96DAC541-7B7A-43D3-8B79-37D633B846F1}">
+                <asvg:svgBlip xmlns:asvg="http://schemas.microsoft.com/office/drawing/2016/SVG/main" r:embed="rId5"/>
+              </a:ext>
+            </a:extLst>
+          </a:blip>
+          <a:srcRect t="11967" b="12054"/>
+          <a:stretch>
+            <a:fillRect/>
+          </a:stretch>
+        </p:blipFill>
+        <p:spPr>
+          <a:xfrm>
+            <a:off x="7809345" y="1514764"/>
+            <a:ext cx="2286000" cy="4045527"/>
+          </a:xfrm>
+          <a:prstGeom prst="rect">
+            <a:avLst/>
+          </a:prstGeom>
+        </p:spPr>
+      </p:pic>
+    </p:spTree>
+    <p:extLst>
+      <p:ext uri="{BB962C8B-B14F-4D97-AF65-F5344CB8AC3E}">
+        <p14:creationId xmlns:p14="http://schemas.microsoft.com/office/powerpoint/2010/main" val="2209804349"/>
       </p:ext>
     </p:extLst>
   </p:cSld>
@@ -2786,6 +2890,14 @@
 </file>
 
 <file path=customXml/item1.xml><?xml version="1.0" encoding="utf-8"?>
+<p:properties xmlns:p="http://schemas.microsoft.com/office/2006/metadata/properties" xmlns:xsi="http://www.w3.org/2001/XMLSchema-instance" xmlns:pc="http://schemas.microsoft.com/office/infopath/2007/PartnerControls">
+  <documentManagement>
+    <_activity xmlns="a4af94e1-c1fc-4949-80ee-6d0f2b25a4fd" xsi:nil="true"/>
+  </documentManagement>
+</p:properties>
+</file>
+
+<file path=customXml/item2.xml><?xml version="1.0" encoding="utf-8"?>
 <ct:contentTypeSchema xmlns:ct="http://schemas.microsoft.com/office/2006/metadata/contentType" xmlns:ma="http://schemas.microsoft.com/office/2006/metadata/properties/metaAttributes" ct:_="" ma:_="" ma:contentTypeName="ドキュメント" ma:contentTypeID="0x01010001977AFA83253148B9A11DE7E57585DA" ma:contentTypeVersion="18" ma:contentTypeDescription="新しいドキュメントを作成します。" ma:contentTypeScope="" ma:versionID="c33b06d1a59709aebae5ef90ac421293">
   <xsd:schema xmlns:xsd="http://www.w3.org/2001/XMLSchema" xmlns:xs="http://www.w3.org/2001/XMLSchema" xmlns:p="http://schemas.microsoft.com/office/2006/metadata/properties" xmlns:ns3="a4af94e1-c1fc-4949-80ee-6d0f2b25a4fd" xmlns:ns4="6e67e666-c3e9-4393-909a-82e166baf630" targetNamespace="http://schemas.microsoft.com/office/2006/metadata/properties" ma:root="true" ma:fieldsID="5929bf68818a63ba6b6aa8003b159019" ns3:_="" ns4:_="">
     <xsd:import namespace="a4af94e1-c1fc-4949-80ee-6d0f2b25a4fd"/>
@@ -3038,14 +3150,6 @@
 </ct:contentTypeSchema>
 </file>
 
-<file path=customXml/item2.xml><?xml version="1.0" encoding="utf-8"?>
-<p:properties xmlns:p="http://schemas.microsoft.com/office/2006/metadata/properties" xmlns:xsi="http://www.w3.org/2001/XMLSchema-instance" xmlns:pc="http://schemas.microsoft.com/office/infopath/2007/PartnerControls">
-  <documentManagement>
-    <_activity xmlns="a4af94e1-c1fc-4949-80ee-6d0f2b25a4fd" xsi:nil="true"/>
-  </documentManagement>
-</p:properties>
-</file>
-
 <file path=customXml/item3.xml><?xml version="1.0" encoding="utf-8"?>
 <?mso-contentType ?>
 <FormTemplates xmlns="http://schemas.microsoft.com/sharepoint/v3/contenttype/forms">
@@ -3056,6 +3160,23 @@
 </file>
 
 <file path=customXml/itemProps1.xml><?xml version="1.0" encoding="utf-8"?>
+<ds:datastoreItem xmlns:ds="http://schemas.openxmlformats.org/officeDocument/2006/customXml" ds:itemID="{B536A920-CFA6-45F7-AAF4-D5E5B2A432A5}">
+  <ds:schemaRefs>
+    <ds:schemaRef ds:uri="http://schemas.microsoft.com/office/infopath/2007/PartnerControls"/>
+    <ds:schemaRef ds:uri="http://schemas.microsoft.com/office/2006/metadata/properties"/>
+    <ds:schemaRef ds:uri="http://schemas.microsoft.com/office/2006/documentManagement/types"/>
+    <ds:schemaRef ds:uri="http://purl.org/dc/elements/1.1/"/>
+    <ds:schemaRef ds:uri="http://purl.org/dc/dcmitype/"/>
+    <ds:schemaRef ds:uri="http://www.w3.org/XML/1998/namespace"/>
+    <ds:schemaRef ds:uri="a4af94e1-c1fc-4949-80ee-6d0f2b25a4fd"/>
+    <ds:schemaRef ds:uri="http://schemas.openxmlformats.org/package/2006/metadata/core-properties"/>
+    <ds:schemaRef ds:uri="6e67e666-c3e9-4393-909a-82e166baf630"/>
+    <ds:schemaRef ds:uri="http://purl.org/dc/terms/"/>
+  </ds:schemaRefs>
+</ds:datastoreItem>
+</file>
+
+<file path=customXml/itemProps2.xml><?xml version="1.0" encoding="utf-8"?>
 <ds:datastoreItem xmlns:ds="http://schemas.openxmlformats.org/officeDocument/2006/customXml" ds:itemID="{4CF7E964-C6F6-44DA-86BC-C4F5D23786D9}">
   <ds:schemaRefs>
     <ds:schemaRef ds:uri="http://schemas.microsoft.com/office/2006/metadata/contentType"/>
@@ -3074,23 +3195,6 @@
 </ds:datastoreItem>
 </file>
 
-<file path=customXml/itemProps2.xml><?xml version="1.0" encoding="utf-8"?>
-<ds:datastoreItem xmlns:ds="http://schemas.openxmlformats.org/officeDocument/2006/customXml" ds:itemID="{B536A920-CFA6-45F7-AAF4-D5E5B2A432A5}">
-  <ds:schemaRefs>
-    <ds:schemaRef ds:uri="http://schemas.microsoft.com/office/infopath/2007/PartnerControls"/>
-    <ds:schemaRef ds:uri="http://schemas.microsoft.com/office/2006/metadata/properties"/>
-    <ds:schemaRef ds:uri="http://schemas.microsoft.com/office/2006/documentManagement/types"/>
-    <ds:schemaRef ds:uri="http://purl.org/dc/elements/1.1/"/>
-    <ds:schemaRef ds:uri="http://purl.org/dc/dcmitype/"/>
-    <ds:schemaRef ds:uri="http://www.w3.org/XML/1998/namespace"/>
-    <ds:schemaRef ds:uri="a4af94e1-c1fc-4949-80ee-6d0f2b25a4fd"/>
-    <ds:schemaRef ds:uri="http://schemas.openxmlformats.org/package/2006/metadata/core-properties"/>
-    <ds:schemaRef ds:uri="6e67e666-c3e9-4393-909a-82e166baf630"/>
-    <ds:schemaRef ds:uri="http://purl.org/dc/terms/"/>
-  </ds:schemaRefs>
-</ds:datastoreItem>
-</file>
-
 <file path=customXml/itemProps3.xml><?xml version="1.0" encoding="utf-8"?>
 <ds:datastoreItem xmlns:ds="http://schemas.openxmlformats.org/officeDocument/2006/customXml" ds:itemID="{A32B4A66-F859-40E3-BB80-2813DE49481C}">
   <ds:schemaRefs>

</xml_diff>